<commit_message>
Week 8 deck: inserted screenshots, resized tiles, added build phases slide
- Slide 6 (live site): four screenshots inserted into the tile placeholders.
  Tile boxes regrown from 1.25" to 1.95" tall (~4:3 aspect that matches
  natural screenshot shape) so images fit cleanly without distortion;
  pictures snapped into the new inner zones preserving aspect ratio.
- New slide 7 (Build phases): five-phase roadmap card (React UI mock →
  FastAPI mock /scan → real rPPG pipeline → Docker + Cloudflare Tunnel
  → browser webcam capture) inserted between "Live site" and "Accuracy".

Co-Authored-By: Claude Opus 4.7 (1M context) <noreply@anthropic.com>
</commit_message>
<xml_diff>
--- a/docs/VitalScan_Group1_Backend_System_Architecture.pptx
+++ b/docs/VitalScan_Group1_Backend_System_Architecture.pptx
@@ -8727,7 +8727,7 @@
             <a:avLst/>
           </a:prstGeom>
           <a:solidFill>
-            <a:srgbClr val="FFFFFF"/>
+            <a:srgbClr val="060F1B"/>
           </a:solidFill>
           <a:ln>
             <a:noFill/>
@@ -8758,23 +8758,201 @@
       </p:sp>
       <p:sp>
         <p:nvSpPr>
-          <p:cNvPr id="3" name="Rectangle 2"/>
-          <p:cNvSpPr/>
-          <p:nvPr/>
-        </p:nvSpPr>
-        <p:spPr>
-          <a:xfrm>
-            <a:off x="0" y="0"/>
-            <a:ext cx="12191695" cy="164592"/>
-          </a:xfrm>
-          <a:prstGeom prst="rect">
+          <p:cNvPr id="3" name="TextBox 2"/>
+          <p:cNvSpPr txBox="1"/>
+          <p:nvPr/>
+        </p:nvSpPr>
+        <p:spPr>
+          <a:xfrm>
+            <a:off x="502920" y="384048"/>
+            <a:ext cx="4389120" cy="438912"/>
+          </a:xfrm>
+          <a:prstGeom prst="rect">
+            <a:avLst/>
+          </a:prstGeom>
+          <a:noFill/>
+        </p:spPr>
+        <p:txBody>
+          <a:bodyPr wrap="none" lIns="0" tIns="0" rIns="0" bIns="0">
+            <a:spAutoFit/>
+          </a:bodyPr>
+          <a:lstStyle/>
+          <a:p>
+            <a:pPr algn="l"/>
+            <a:r>
+              <a:rPr sz="2600" b="1">
+                <a:solidFill>
+                  <a:srgbClr val="F1F7FF"/>
+                </a:solidFill>
+                <a:latin typeface="Aptos"/>
+              </a:rPr>
+              <a:t>Build phases</a:t>
+            </a:r>
+          </a:p>
+        </p:txBody>
+      </p:sp>
+      <p:sp>
+        <p:nvSpPr>
+          <p:cNvPr id="4" name="TextBox 3"/>
+          <p:cNvSpPr txBox="1"/>
+          <p:nvPr/>
+        </p:nvSpPr>
+        <p:spPr>
+          <a:xfrm>
+            <a:off x="512064" y="841248"/>
+            <a:ext cx="6492240" cy="256032"/>
+          </a:xfrm>
+          <a:prstGeom prst="rect">
+            <a:avLst/>
+          </a:prstGeom>
+          <a:noFill/>
+        </p:spPr>
+        <p:txBody>
+          <a:bodyPr wrap="none" lIns="0" tIns="0" rIns="0" bIns="0">
+            <a:spAutoFit/>
+          </a:bodyPr>
+          <a:lstStyle/>
+          <a:p>
+            <a:pPr algn="l"/>
+            <a:r>
+              <a:rPr sz="1250" b="1">
+                <a:solidFill>
+                  <a:srgbClr val="97A8BE"/>
+                </a:solidFill>
+                <a:latin typeface="Aptos"/>
+              </a:rPr>
+              <a:t>From project brief → live product → evaluated rPPG pipeline</a:t>
+            </a:r>
+          </a:p>
+        </p:txBody>
+      </p:sp>
+      <p:sp>
+        <p:nvSpPr>
+          <p:cNvPr id="5" name="TextBox 4"/>
+          <p:cNvSpPr txBox="1"/>
+          <p:nvPr/>
+        </p:nvSpPr>
+        <p:spPr>
+          <a:xfrm>
+            <a:off x="8001000" y="438912"/>
+            <a:ext cx="2148840" cy="228600"/>
+          </a:xfrm>
+          <a:prstGeom prst="rect">
+            <a:avLst/>
+          </a:prstGeom>
+          <a:noFill/>
+        </p:spPr>
+        <p:txBody>
+          <a:bodyPr wrap="none" lIns="0" tIns="0" rIns="0" bIns="0">
+            <a:spAutoFit/>
+          </a:bodyPr>
+          <a:lstStyle/>
+          <a:p>
+            <a:pPr algn="r"/>
+            <a:r>
+              <a:rPr sz="780" b="0">
+                <a:solidFill>
+                  <a:srgbClr val="97A8BE"/>
+                </a:solidFill>
+                <a:latin typeface="Aptos"/>
+              </a:rPr>
+              <a:t>VitalScan · AIT 500 · Group 1 · Week 8</a:t>
+            </a:r>
+          </a:p>
+        </p:txBody>
+      </p:sp>
+      <p:sp>
+        <p:nvSpPr>
+          <p:cNvPr id="6" name="TextBox 5"/>
+          <p:cNvSpPr txBox="1"/>
+          <p:nvPr/>
+        </p:nvSpPr>
+        <p:spPr>
+          <a:xfrm>
+            <a:off x="10195560" y="420624"/>
+            <a:ext cx="1051560" cy="329184"/>
+          </a:xfrm>
+          <a:prstGeom prst="rect">
+            <a:avLst/>
+          </a:prstGeom>
+          <a:noFill/>
+        </p:spPr>
+        <p:txBody>
+          <a:bodyPr wrap="none" lIns="0" tIns="0" rIns="0" bIns="0">
+            <a:spAutoFit/>
+          </a:bodyPr>
+          <a:lstStyle/>
+          <a:p>
+            <a:pPr algn="r"/>
+            <a:r>
+              <a:rPr sz="750" b="1">
+                <a:solidFill>
+                  <a:srgbClr val="26CB7C"/>
+                </a:solidFill>
+                <a:latin typeface="Aptos"/>
+              </a:rPr>
+              <a:t>presented by
+Germaine</a:t>
+            </a:r>
+          </a:p>
+        </p:txBody>
+      </p:sp>
+      <p:cxnSp>
+        <p:nvCxnSpPr>
+          <p:cNvPr id="7" name="Connector 6"/>
+          <p:cNvCxnSpPr/>
+          <p:nvPr/>
+        </p:nvCxnSpPr>
+        <p:spPr>
+          <a:xfrm>
+            <a:off x="502920" y="1124712"/>
+            <a:ext cx="10698480" cy="0"/>
+          </a:xfrm>
+          <a:prstGeom prst="line">
+            <a:avLst/>
+          </a:prstGeom>
+          <a:ln w="9525">
+            <a:solidFill>
+              <a:srgbClr val="223F5D"/>
+            </a:solidFill>
+          </a:ln>
+        </p:spPr>
+        <p:style>
+          <a:lnRef idx="2">
+            <a:schemeClr val="accent1"/>
+          </a:lnRef>
+          <a:fillRef idx="0">
+            <a:schemeClr val="accent1"/>
+          </a:fillRef>
+          <a:effectRef idx="1">
+            <a:schemeClr val="accent1"/>
+          </a:effectRef>
+          <a:fontRef idx="minor">
+            <a:schemeClr val="tx1"/>
+          </a:fontRef>
+        </p:style>
+      </p:cxnSp>
+      <p:sp>
+        <p:nvSpPr>
+          <p:cNvPr id="8" name="Rounded Rectangle 7"/>
+          <p:cNvSpPr/>
+          <p:nvPr/>
+        </p:nvSpPr>
+        <p:spPr>
+          <a:xfrm>
+            <a:off x="413925" y="1335024"/>
+            <a:ext cx="10698480" cy="4315968"/>
+          </a:xfrm>
+          <a:prstGeom prst="roundRect">
             <a:avLst/>
           </a:prstGeom>
           <a:solidFill>
-            <a:srgbClr val="1F6FEB"/>
+            <a:srgbClr val="081422"/>
           </a:solidFill>
-          <a:ln>
-            <a:noFill/>
+          <a:ln w="12700">
+            <a:solidFill>
+              <a:srgbClr val="16344E"/>
+            </a:solidFill>
           </a:ln>
         </p:spPr>
         <p:style>
@@ -8802,201 +8980,94 @@
       </p:sp>
       <p:sp>
         <p:nvSpPr>
-          <p:cNvPr id="4" name="TextBox 3"/>
+          <p:cNvPr id="9" name="TextBox 8"/>
           <p:cNvSpPr txBox="1"/>
           <p:nvPr/>
         </p:nvSpPr>
         <p:spPr>
           <a:xfrm>
-            <a:off x="457200" y="329184"/>
-            <a:ext cx="11247120" cy="411480"/>
-          </a:xfrm>
-          <a:prstGeom prst="rect">
-            <a:avLst/>
-          </a:prstGeom>
-          <a:noFill/>
-        </p:spPr>
-        <p:txBody>
-          <a:bodyPr wrap="square" lIns="0" tIns="0" rIns="0" bIns="0">
+            <a:off x="749808" y="1517904"/>
+            <a:ext cx="2011680" cy="201168"/>
+          </a:xfrm>
+          <a:prstGeom prst="rect">
+            <a:avLst/>
+          </a:prstGeom>
+          <a:noFill/>
+        </p:spPr>
+        <p:txBody>
+          <a:bodyPr wrap="none" lIns="0" tIns="0" rIns="0" bIns="0">
             <a:spAutoFit/>
           </a:bodyPr>
           <a:lstStyle/>
           <a:p>
             <a:pPr algn="l"/>
             <a:r>
-              <a:rPr sz="2800" b="1">
-                <a:solidFill>
-                  <a:srgbClr val="0F1F44"/>
-                </a:solidFill>
-                <a:latin typeface="Calibri"/>
-              </a:rPr>
-              <a:t>Build phases</a:t>
-            </a:r>
-          </a:p>
-        </p:txBody>
-      </p:sp>
-      <p:sp>
-        <p:nvSpPr>
-          <p:cNvPr id="5" name="TextBox 4"/>
-          <p:cNvSpPr txBox="1"/>
-          <p:nvPr/>
-        </p:nvSpPr>
-        <p:spPr>
-          <a:xfrm>
-            <a:off x="530352" y="813816"/>
-            <a:ext cx="7772400" cy="274320"/>
-          </a:xfrm>
-          <a:prstGeom prst="rect">
-            <a:avLst/>
-          </a:prstGeom>
-          <a:noFill/>
-        </p:spPr>
-        <p:txBody>
-          <a:bodyPr wrap="square" lIns="0" tIns="0" rIns="0" bIns="0">
-            <a:spAutoFit/>
-          </a:bodyPr>
-          <a:lstStyle/>
-          <a:p>
-            <a:pPr algn="l"/>
-            <a:r>
-              <a:rPr sz="1400" b="0">
-                <a:solidFill>
-                  <a:srgbClr val="55667A"/>
-                </a:solidFill>
-                <a:latin typeface="Calibri"/>
-              </a:rPr>
-              <a:t>How we got from project brief to a live, working product</a:t>
-            </a:r>
-          </a:p>
-        </p:txBody>
-      </p:sp>
-      <p:sp>
-        <p:nvSpPr>
-          <p:cNvPr id="6" name="TextBox 5"/>
-          <p:cNvSpPr txBox="1"/>
-          <p:nvPr/>
-        </p:nvSpPr>
-        <p:spPr>
-          <a:xfrm>
-            <a:off x="8549640" y="384048"/>
-            <a:ext cx="2240280" cy="228600"/>
-          </a:xfrm>
-          <a:prstGeom prst="rect">
-            <a:avLst/>
-          </a:prstGeom>
-          <a:noFill/>
-        </p:spPr>
-        <p:txBody>
-          <a:bodyPr wrap="square" lIns="0" tIns="0" rIns="0" bIns="0">
-            <a:spAutoFit/>
-          </a:bodyPr>
-          <a:lstStyle/>
-          <a:p>
-            <a:pPr algn="l"/>
-            <a:r>
-              <a:rPr sz="1000" b="0">
-                <a:solidFill>
-                  <a:srgbClr val="55667A"/>
-                </a:solidFill>
-                <a:latin typeface="Calibri"/>
-              </a:rPr>
-              <a:t>VitalScan · AIT 500 · Group 1 · Week 8</a:t>
-            </a:r>
-          </a:p>
-        </p:txBody>
-      </p:sp>
-      <p:sp>
-        <p:nvSpPr>
-          <p:cNvPr id="7" name="TextBox 6"/>
-          <p:cNvSpPr txBox="1"/>
-          <p:nvPr/>
-        </p:nvSpPr>
-        <p:spPr>
-          <a:xfrm>
-            <a:off x="10835640" y="384048"/>
-            <a:ext cx="868680" cy="228600"/>
-          </a:xfrm>
-          <a:prstGeom prst="rect">
-            <a:avLst/>
-          </a:prstGeom>
-          <a:noFill/>
-        </p:spPr>
-        <p:txBody>
-          <a:bodyPr wrap="square" lIns="0" tIns="0" rIns="0" bIns="0">
-            <a:spAutoFit/>
-          </a:bodyPr>
-          <a:lstStyle/>
-          <a:p>
-            <a:pPr algn="r"/>
-            <a:r>
-              <a:rPr sz="1000" b="0">
-                <a:solidFill>
-                  <a:srgbClr val="1F6FEB"/>
-                </a:solidFill>
-                <a:latin typeface="Calibri"/>
-              </a:rPr>
-              <a:t>presented by Germaine</a:t>
-            </a:r>
-          </a:p>
-        </p:txBody>
-      </p:sp>
-      <p:sp>
-        <p:nvSpPr>
-          <p:cNvPr id="8" name="TextBox 7"/>
-          <p:cNvSpPr txBox="1"/>
-          <p:nvPr/>
-        </p:nvSpPr>
-        <p:spPr>
-          <a:xfrm>
-            <a:off x="457200" y="6601968"/>
-            <a:ext cx="7315200" cy="182880"/>
-          </a:xfrm>
-          <a:prstGeom prst="rect">
-            <a:avLst/>
-          </a:prstGeom>
-          <a:noFill/>
-        </p:spPr>
-        <p:txBody>
-          <a:bodyPr wrap="square" lIns="0" tIns="0" rIns="0" bIns="0">
-            <a:spAutoFit/>
-          </a:bodyPr>
-          <a:lstStyle/>
-          <a:p>
-            <a:pPr algn="l"/>
-            <a:r>
-              <a:rPr sz="1000" b="0">
-                <a:solidFill>
-                  <a:srgbClr val="55667A"/>
-                </a:solidFill>
-                <a:latin typeface="Calibri"/>
-              </a:rPr>
-              <a:t>vitalscan.bkre8tive.com  ·  github.com/gbiz21/vitalscan</a:t>
-            </a:r>
-          </a:p>
-        </p:txBody>
-      </p:sp>
-      <p:sp>
-        <p:nvSpPr>
-          <p:cNvPr id="9" name="Rounded Rectangle 8"/>
-          <p:cNvSpPr/>
-          <p:nvPr/>
-        </p:nvSpPr>
-        <p:spPr>
-          <a:xfrm>
-            <a:off x="685800" y="1280160"/>
-            <a:ext cx="10789920" cy="777240"/>
+              <a:rPr sz="900" b="1" dirty="0">
+                <a:solidFill>
+                  <a:srgbClr val="26CB7C"/>
+                </a:solidFill>
+                <a:latin typeface="Aptos"/>
+              </a:rPr>
+              <a:t>BUILD SEQUENCE</a:t>
+            </a:r>
+          </a:p>
+        </p:txBody>
+      </p:sp>
+      <p:cxnSp>
+        <p:nvCxnSpPr>
+          <p:cNvPr id="10" name="Connector 9"/>
+          <p:cNvCxnSpPr/>
+          <p:nvPr/>
+        </p:nvCxnSpPr>
+        <p:spPr>
+          <a:xfrm>
+            <a:off x="1060704" y="1874519"/>
+            <a:ext cx="0" cy="3319273"/>
+          </a:xfrm>
+          <a:prstGeom prst="line">
+            <a:avLst/>
+          </a:prstGeom>
+          <a:ln w="25400">
+            <a:solidFill>
+              <a:srgbClr val="1B545F"/>
+            </a:solidFill>
+          </a:ln>
+        </p:spPr>
+        <p:style>
+          <a:lnRef idx="2">
+            <a:schemeClr val="accent1"/>
+          </a:lnRef>
+          <a:fillRef idx="0">
+            <a:schemeClr val="accent1"/>
+          </a:fillRef>
+          <a:effectRef idx="1">
+            <a:schemeClr val="accent1"/>
+          </a:effectRef>
+          <a:fontRef idx="minor">
+            <a:schemeClr val="tx1"/>
+          </a:fontRef>
+        </p:style>
+      </p:cxnSp>
+      <p:sp>
+        <p:nvSpPr>
+          <p:cNvPr id="11" name="Rounded Rectangle 10"/>
+          <p:cNvSpPr/>
+          <p:nvPr/>
+        </p:nvSpPr>
+        <p:spPr>
+          <a:xfrm>
+            <a:off x="786384" y="1773936"/>
+            <a:ext cx="6903720" cy="658368"/>
           </a:xfrm>
           <a:prstGeom prst="roundRect">
-            <a:avLst>
-              <a:gd name="adj" fmla="val 18000"/>
-            </a:avLst>
+            <a:avLst/>
           </a:prstGeom>
           <a:solidFill>
-            <a:srgbClr val="F6F8FB"/>
+            <a:srgbClr val="0E1E2F"/>
           </a:solidFill>
-          <a:ln w="12700">
+          <a:ln w="11430">
             <a:solidFill>
-              <a:srgbClr val="1F6FEB"/>
+              <a:srgbClr val="244869"/>
             </a:solidFill>
           </a:ln>
         </p:spPr>
@@ -9025,20 +9096,20 @@
       </p:sp>
       <p:sp>
         <p:nvSpPr>
-          <p:cNvPr id="10" name="Oval 9"/>
-          <p:cNvSpPr/>
-          <p:nvPr/>
-        </p:nvSpPr>
-        <p:spPr>
-          <a:xfrm>
-            <a:off x="914400" y="1472184"/>
-            <a:ext cx="384048" cy="384048"/>
+          <p:cNvPr id="12" name="Oval 11"/>
+          <p:cNvSpPr/>
+          <p:nvPr/>
+        </p:nvSpPr>
+        <p:spPr>
+          <a:xfrm>
+            <a:off x="905256" y="1947672"/>
+            <a:ext cx="301752" cy="301752"/>
           </a:xfrm>
           <a:prstGeom prst="ellipse">
             <a:avLst/>
           </a:prstGeom>
           <a:solidFill>
-            <a:srgbClr val="1E884F"/>
+            <a:srgbClr val="26CB7C"/>
           </a:solidFill>
           <a:ln>
             <a:noFill/>
@@ -9069,33 +9140,33 @@
       </p:sp>
       <p:sp>
         <p:nvSpPr>
-          <p:cNvPr id="11" name="TextBox 10"/>
+          <p:cNvPr id="13" name="TextBox 12"/>
           <p:cNvSpPr txBox="1"/>
           <p:nvPr/>
         </p:nvSpPr>
         <p:spPr>
           <a:xfrm>
-            <a:off x="914400" y="1481328"/>
-            <a:ext cx="384048" cy="384048"/>
-          </a:xfrm>
-          <a:prstGeom prst="rect">
-            <a:avLst/>
-          </a:prstGeom>
-          <a:noFill/>
-        </p:spPr>
-        <p:txBody>
-          <a:bodyPr wrap="square" lIns="0" tIns="0" rIns="0" bIns="0">
+            <a:off x="964692" y="1947672"/>
+            <a:ext cx="182880" cy="237744"/>
+          </a:xfrm>
+          <a:prstGeom prst="rect">
+            <a:avLst/>
+          </a:prstGeom>
+          <a:noFill/>
+        </p:spPr>
+        <p:txBody>
+          <a:bodyPr wrap="none" lIns="0" tIns="0" rIns="0" bIns="0">
             <a:spAutoFit/>
           </a:bodyPr>
           <a:lstStyle/>
           <a:p>
             <a:pPr algn="ctr"/>
             <a:r>
-              <a:rPr sz="1800" b="1">
-                <a:solidFill>
-                  <a:srgbClr val="FFFFFF"/>
-                </a:solidFill>
-                <a:latin typeface="Calibri"/>
+              <a:rPr sz="1300" b="1" dirty="0">
+                <a:solidFill>
+                  <a:srgbClr val="060F1B"/>
+                </a:solidFill>
+                <a:latin typeface="Aptos"/>
               </a:rPr>
               <a:t>✓</a:t>
             </a:r>
@@ -9104,33 +9175,33 @@
       </p:sp>
       <p:sp>
         <p:nvSpPr>
-          <p:cNvPr id="12" name="TextBox 11"/>
+          <p:cNvPr id="14" name="TextBox 13"/>
           <p:cNvSpPr txBox="1"/>
           <p:nvPr/>
         </p:nvSpPr>
         <p:spPr>
           <a:xfrm>
-            <a:off x="1508760" y="1444752"/>
-            <a:ext cx="1188720" cy="365760"/>
-          </a:xfrm>
-          <a:prstGeom prst="rect">
-            <a:avLst/>
-          </a:prstGeom>
-          <a:noFill/>
-        </p:spPr>
-        <p:txBody>
-          <a:bodyPr wrap="square" lIns="0" tIns="0" rIns="0" bIns="0">
+            <a:off x="1353312" y="1920240"/>
+            <a:ext cx="786384" cy="228600"/>
+          </a:xfrm>
+          <a:prstGeom prst="rect">
+            <a:avLst/>
+          </a:prstGeom>
+          <a:noFill/>
+        </p:spPr>
+        <p:txBody>
+          <a:bodyPr wrap="none" lIns="0" tIns="0" rIns="0" bIns="0">
             <a:spAutoFit/>
           </a:bodyPr>
           <a:lstStyle/>
           <a:p>
             <a:pPr algn="l"/>
             <a:r>
-              <a:rPr sz="1400" b="1">
-                <a:solidFill>
-                  <a:srgbClr val="1F6FEB"/>
-                </a:solidFill>
-                <a:latin typeface="Calibri"/>
+              <a:rPr sz="1000" b="1" dirty="0">
+                <a:solidFill>
+                  <a:srgbClr val="26CB7C"/>
+                </a:solidFill>
+                <a:latin typeface="Aptos"/>
               </a:rPr>
               <a:t>Phase 1</a:t>
             </a:r>
@@ -9139,96 +9210,95 @@
       </p:sp>
       <p:sp>
         <p:nvSpPr>
-          <p:cNvPr id="13" name="TextBox 12"/>
+          <p:cNvPr id="15" name="TextBox 14"/>
           <p:cNvSpPr txBox="1"/>
           <p:nvPr/>
         </p:nvSpPr>
         <p:spPr>
           <a:xfrm>
-            <a:off x="2743200" y="1426464"/>
-            <a:ext cx="8595360" cy="365760"/>
-          </a:xfrm>
-          <a:prstGeom prst="rect">
-            <a:avLst/>
-          </a:prstGeom>
-          <a:noFill/>
-        </p:spPr>
-        <p:txBody>
-          <a:bodyPr wrap="square" lIns="0" tIns="0" rIns="0" bIns="0">
+            <a:off x="2331720" y="1892807"/>
+            <a:ext cx="2057400" cy="256032"/>
+          </a:xfrm>
+          <a:prstGeom prst="rect">
+            <a:avLst/>
+          </a:prstGeom>
+          <a:noFill/>
+        </p:spPr>
+        <p:txBody>
+          <a:bodyPr wrap="none" lIns="0" tIns="0" rIns="0" bIns="0">
             <a:spAutoFit/>
           </a:bodyPr>
           <a:lstStyle/>
           <a:p>
             <a:pPr algn="l"/>
             <a:r>
-              <a:rPr sz="1600" b="1">
-                <a:solidFill>
-                  <a:srgbClr val="0F1F44"/>
-                </a:solidFill>
-                <a:latin typeface="Calibri"/>
-              </a:rPr>
-              <a:t>React UI with mock biomarker data</a:t>
-            </a:r>
-          </a:p>
-        </p:txBody>
-      </p:sp>
-      <p:sp>
-        <p:nvSpPr>
-          <p:cNvPr id="14" name="TextBox 13"/>
+              <a:rPr sz="1450" b="1">
+                <a:solidFill>
+                  <a:srgbClr val="F1F7FF"/>
+                </a:solidFill>
+                <a:latin typeface="Aptos"/>
+              </a:rPr>
+              <a:t>React UI mock</a:t>
+            </a:r>
+          </a:p>
+        </p:txBody>
+      </p:sp>
+      <p:sp>
+        <p:nvSpPr>
+          <p:cNvPr id="16" name="TextBox 15"/>
           <p:cNvSpPr txBox="1"/>
           <p:nvPr/>
         </p:nvSpPr>
         <p:spPr>
           <a:xfrm>
-            <a:off x="2743200" y="1737360"/>
-            <a:ext cx="8595360" cy="274320"/>
-          </a:xfrm>
-          <a:prstGeom prst="rect">
-            <a:avLst/>
-          </a:prstGeom>
-          <a:noFill/>
-        </p:spPr>
-        <p:txBody>
-          <a:bodyPr wrap="square" lIns="0" tIns="0" rIns="0" bIns="0">
+            <a:off x="2331720" y="2157984"/>
+            <a:ext cx="4526280" cy="228600"/>
+          </a:xfrm>
+          <a:prstGeom prst="rect">
+            <a:avLst/>
+          </a:prstGeom>
+          <a:noFill/>
+        </p:spPr>
+        <p:txBody>
+          <a:bodyPr wrap="none" lIns="0" tIns="0" rIns="0" bIns="0">
             <a:spAutoFit/>
           </a:bodyPr>
           <a:lstStyle/>
           <a:p>
             <a:pPr algn="l"/>
             <a:r>
-              <a:rPr sz="1100" b="0">
-                <a:solidFill>
-                  <a:srgbClr val="55667A"/>
-                </a:solidFill>
-                <a:latin typeface="Calibri"/>
-              </a:rPr>
-              <a:t>Got the dashboard, body figure, and biomarker cards working against fake data first.</a:t>
-            </a:r>
-          </a:p>
-        </p:txBody>
-      </p:sp>
-      <p:sp>
-        <p:nvSpPr>
-          <p:cNvPr id="15" name="Rounded Rectangle 14"/>
-          <p:cNvSpPr/>
-          <p:nvPr/>
-        </p:nvSpPr>
-        <p:spPr>
-          <a:xfrm>
-            <a:off x="685800" y="2240280"/>
-            <a:ext cx="10789920" cy="777240"/>
+              <a:rPr sz="880" b="0">
+                <a:solidFill>
+                  <a:srgbClr val="97A8BE"/>
+                </a:solidFill>
+                <a:latin typeface="Aptos"/>
+              </a:rPr>
+              <a:t>Dashboard, body figure, and biomarker cards
+working first with sample JSON.</a:t>
+            </a:r>
+          </a:p>
+        </p:txBody>
+      </p:sp>
+      <p:sp>
+        <p:nvSpPr>
+          <p:cNvPr id="17" name="Rounded Rectangle 16"/>
+          <p:cNvSpPr/>
+          <p:nvPr/>
+        </p:nvSpPr>
+        <p:spPr>
+          <a:xfrm>
+            <a:off x="786384" y="2487168"/>
+            <a:ext cx="6903720" cy="658368"/>
           </a:xfrm>
           <a:prstGeom prst="roundRect">
-            <a:avLst>
-              <a:gd name="adj" fmla="val 18000"/>
-            </a:avLst>
+            <a:avLst/>
           </a:prstGeom>
           <a:solidFill>
-            <a:srgbClr val="F6F8FB"/>
+            <a:srgbClr val="0E1E2F"/>
           </a:solidFill>
-          <a:ln w="12700">
+          <a:ln w="11430">
             <a:solidFill>
-              <a:srgbClr val="1F6FEB"/>
+              <a:srgbClr val="244869"/>
             </a:solidFill>
           </a:ln>
         </p:spPr>
@@ -9257,20 +9327,20 @@
       </p:sp>
       <p:sp>
         <p:nvSpPr>
-          <p:cNvPr id="16" name="Oval 15"/>
-          <p:cNvSpPr/>
-          <p:nvPr/>
-        </p:nvSpPr>
-        <p:spPr>
-          <a:xfrm>
-            <a:off x="914400" y="2432304"/>
-            <a:ext cx="384048" cy="384048"/>
+          <p:cNvPr id="18" name="Oval 17"/>
+          <p:cNvSpPr/>
+          <p:nvPr/>
+        </p:nvSpPr>
+        <p:spPr>
+          <a:xfrm>
+            <a:off x="905256" y="2660903"/>
+            <a:ext cx="301752" cy="301752"/>
           </a:xfrm>
           <a:prstGeom prst="ellipse">
             <a:avLst/>
           </a:prstGeom>
           <a:solidFill>
-            <a:srgbClr val="1E884F"/>
+            <a:srgbClr val="26CB7C"/>
           </a:solidFill>
           <a:ln>
             <a:noFill/>
@@ -9301,33 +9371,33 @@
       </p:sp>
       <p:sp>
         <p:nvSpPr>
-          <p:cNvPr id="17" name="TextBox 16"/>
+          <p:cNvPr id="19" name="TextBox 18"/>
           <p:cNvSpPr txBox="1"/>
           <p:nvPr/>
         </p:nvSpPr>
         <p:spPr>
           <a:xfrm>
-            <a:off x="914400" y="2441448"/>
-            <a:ext cx="384048" cy="384048"/>
-          </a:xfrm>
-          <a:prstGeom prst="rect">
-            <a:avLst/>
-          </a:prstGeom>
-          <a:noFill/>
-        </p:spPr>
-        <p:txBody>
-          <a:bodyPr wrap="square" lIns="0" tIns="0" rIns="0" bIns="0">
+            <a:off x="964692" y="2660903"/>
+            <a:ext cx="182880" cy="237744"/>
+          </a:xfrm>
+          <a:prstGeom prst="rect">
+            <a:avLst/>
+          </a:prstGeom>
+          <a:noFill/>
+        </p:spPr>
+        <p:txBody>
+          <a:bodyPr wrap="none" lIns="0" tIns="0" rIns="0" bIns="0">
             <a:spAutoFit/>
           </a:bodyPr>
           <a:lstStyle/>
           <a:p>
             <a:pPr algn="ctr"/>
             <a:r>
-              <a:rPr sz="1800" b="1">
-                <a:solidFill>
-                  <a:srgbClr val="FFFFFF"/>
-                </a:solidFill>
-                <a:latin typeface="Calibri"/>
+              <a:rPr sz="1300" b="1">
+                <a:solidFill>
+                  <a:srgbClr val="060F1B"/>
+                </a:solidFill>
+                <a:latin typeface="Aptos"/>
               </a:rPr>
               <a:t>✓</a:t>
             </a:r>
@@ -9336,33 +9406,33 @@
       </p:sp>
       <p:sp>
         <p:nvSpPr>
-          <p:cNvPr id="18" name="TextBox 17"/>
+          <p:cNvPr id="20" name="TextBox 19"/>
           <p:cNvSpPr txBox="1"/>
           <p:nvPr/>
         </p:nvSpPr>
         <p:spPr>
           <a:xfrm>
-            <a:off x="1508760" y="2404872"/>
-            <a:ext cx="1188720" cy="365760"/>
-          </a:xfrm>
-          <a:prstGeom prst="rect">
-            <a:avLst/>
-          </a:prstGeom>
-          <a:noFill/>
-        </p:spPr>
-        <p:txBody>
-          <a:bodyPr wrap="square" lIns="0" tIns="0" rIns="0" bIns="0">
+            <a:off x="1353312" y="2633472"/>
+            <a:ext cx="786384" cy="228600"/>
+          </a:xfrm>
+          <a:prstGeom prst="rect">
+            <a:avLst/>
+          </a:prstGeom>
+          <a:noFill/>
+        </p:spPr>
+        <p:txBody>
+          <a:bodyPr wrap="none" lIns="0" tIns="0" rIns="0" bIns="0">
             <a:spAutoFit/>
           </a:bodyPr>
           <a:lstStyle/>
           <a:p>
             <a:pPr algn="l"/>
             <a:r>
-              <a:rPr sz="1400" b="1">
-                <a:solidFill>
-                  <a:srgbClr val="1F6FEB"/>
-                </a:solidFill>
-                <a:latin typeface="Calibri"/>
+              <a:rPr sz="1000" b="1">
+                <a:solidFill>
+                  <a:srgbClr val="26CB7C"/>
+                </a:solidFill>
+                <a:latin typeface="Aptos"/>
               </a:rPr>
               <a:t>Phase 2</a:t>
             </a:r>
@@ -9371,96 +9441,95 @@
       </p:sp>
       <p:sp>
         <p:nvSpPr>
-          <p:cNvPr id="19" name="TextBox 18"/>
+          <p:cNvPr id="21" name="TextBox 20"/>
           <p:cNvSpPr txBox="1"/>
           <p:nvPr/>
         </p:nvSpPr>
         <p:spPr>
           <a:xfrm>
-            <a:off x="2743200" y="2386584"/>
-            <a:ext cx="8595360" cy="365760"/>
-          </a:xfrm>
-          <a:prstGeom prst="rect">
-            <a:avLst/>
-          </a:prstGeom>
-          <a:noFill/>
-        </p:spPr>
-        <p:txBody>
-          <a:bodyPr wrap="square" lIns="0" tIns="0" rIns="0" bIns="0">
+            <a:off x="2331720" y="2606039"/>
+            <a:ext cx="2057400" cy="256032"/>
+          </a:xfrm>
+          <a:prstGeom prst="rect">
+            <a:avLst/>
+          </a:prstGeom>
+          <a:noFill/>
+        </p:spPr>
+        <p:txBody>
+          <a:bodyPr wrap="none" lIns="0" tIns="0" rIns="0" bIns="0">
             <a:spAutoFit/>
           </a:bodyPr>
           <a:lstStyle/>
           <a:p>
             <a:pPr algn="l"/>
             <a:r>
-              <a:rPr sz="1600" b="1">
-                <a:solidFill>
-                  <a:srgbClr val="0F1F44"/>
-                </a:solidFill>
-                <a:latin typeface="Calibri"/>
-              </a:rPr>
-              <a:t>FastAPI backend with mock /scan</a:t>
-            </a:r>
-          </a:p>
-        </p:txBody>
-      </p:sp>
-      <p:sp>
-        <p:nvSpPr>
-          <p:cNvPr id="20" name="TextBox 19"/>
+              <a:rPr sz="1450" b="1">
+                <a:solidFill>
+                  <a:srgbClr val="F1F7FF"/>
+                </a:solidFill>
+                <a:latin typeface="Aptos"/>
+              </a:rPr>
+              <a:t>FastAPI /scan</a:t>
+            </a:r>
+          </a:p>
+        </p:txBody>
+      </p:sp>
+      <p:sp>
+        <p:nvSpPr>
+          <p:cNvPr id="22" name="TextBox 21"/>
           <p:cNvSpPr txBox="1"/>
           <p:nvPr/>
         </p:nvSpPr>
         <p:spPr>
           <a:xfrm>
-            <a:off x="2743200" y="2697480"/>
-            <a:ext cx="8595360" cy="274320"/>
-          </a:xfrm>
-          <a:prstGeom prst="rect">
-            <a:avLst/>
-          </a:prstGeom>
-          <a:noFill/>
-        </p:spPr>
-        <p:txBody>
-          <a:bodyPr wrap="square" lIns="0" tIns="0" rIns="0" bIns="0">
+            <a:off x="2331720" y="2871215"/>
+            <a:ext cx="4526280" cy="228600"/>
+          </a:xfrm>
+          <a:prstGeom prst="rect">
+            <a:avLst/>
+          </a:prstGeom>
+          <a:noFill/>
+        </p:spPr>
+        <p:txBody>
+          <a:bodyPr wrap="none" lIns="0" tIns="0" rIns="0" bIns="0">
             <a:spAutoFit/>
           </a:bodyPr>
           <a:lstStyle/>
           <a:p>
             <a:pPr algn="l"/>
             <a:r>
-              <a:rPr sz="1100" b="0">
-                <a:solidFill>
-                  <a:srgbClr val="55667A"/>
-                </a:solidFill>
-                <a:latin typeface="Calibri"/>
-              </a:rPr>
-              <a:t>Stood up the /scan endpoint returning the shared JSON contract — no rPPG yet.</a:t>
-            </a:r>
-          </a:p>
-        </p:txBody>
-      </p:sp>
-      <p:sp>
-        <p:nvSpPr>
-          <p:cNvPr id="21" name="Rounded Rectangle 20"/>
-          <p:cNvSpPr/>
-          <p:nvPr/>
-        </p:nvSpPr>
-        <p:spPr>
-          <a:xfrm>
-            <a:off x="685800" y="3200400"/>
-            <a:ext cx="10789920" cy="777240"/>
+              <a:rPr sz="880" b="0">
+                <a:solidFill>
+                  <a:srgbClr val="97A8BE"/>
+                </a:solidFill>
+                <a:latin typeface="Aptos"/>
+              </a:rPr>
+              <a:t>Backend endpoint receives video and returns
+the shared biomarker JSON contract.</a:t>
+            </a:r>
+          </a:p>
+        </p:txBody>
+      </p:sp>
+      <p:sp>
+        <p:nvSpPr>
+          <p:cNvPr id="23" name="Rounded Rectangle 22"/>
+          <p:cNvSpPr/>
+          <p:nvPr/>
+        </p:nvSpPr>
+        <p:spPr>
+          <a:xfrm>
+            <a:off x="786384" y="3200400"/>
+            <a:ext cx="6903720" cy="658368"/>
           </a:xfrm>
           <a:prstGeom prst="roundRect">
-            <a:avLst>
-              <a:gd name="adj" fmla="val 18000"/>
-            </a:avLst>
+            <a:avLst/>
           </a:prstGeom>
           <a:solidFill>
-            <a:srgbClr val="F6F8FB"/>
+            <a:srgbClr val="0E1E2F"/>
           </a:solidFill>
-          <a:ln w="12700">
+          <a:ln w="11430">
             <a:solidFill>
-              <a:srgbClr val="1F6FEB"/>
+              <a:srgbClr val="244869"/>
             </a:solidFill>
           </a:ln>
         </p:spPr>
@@ -9489,20 +9558,20 @@
       </p:sp>
       <p:sp>
         <p:nvSpPr>
-          <p:cNvPr id="22" name="Oval 21"/>
-          <p:cNvSpPr/>
-          <p:nvPr/>
-        </p:nvSpPr>
-        <p:spPr>
-          <a:xfrm>
-            <a:off x="914400" y="3392424"/>
-            <a:ext cx="384048" cy="384048"/>
+          <p:cNvPr id="24" name="Oval 23"/>
+          <p:cNvSpPr/>
+          <p:nvPr/>
+        </p:nvSpPr>
+        <p:spPr>
+          <a:xfrm>
+            <a:off x="905256" y="3374136"/>
+            <a:ext cx="301752" cy="301752"/>
           </a:xfrm>
           <a:prstGeom prst="ellipse">
             <a:avLst/>
           </a:prstGeom>
           <a:solidFill>
-            <a:srgbClr val="1E884F"/>
+            <a:srgbClr val="37D5DC"/>
           </a:solidFill>
           <a:ln>
             <a:noFill/>
@@ -9533,33 +9602,33 @@
       </p:sp>
       <p:sp>
         <p:nvSpPr>
-          <p:cNvPr id="23" name="TextBox 22"/>
+          <p:cNvPr id="25" name="TextBox 24"/>
           <p:cNvSpPr txBox="1"/>
           <p:nvPr/>
         </p:nvSpPr>
         <p:spPr>
           <a:xfrm>
-            <a:off x="914400" y="3401568"/>
-            <a:ext cx="384048" cy="384048"/>
-          </a:xfrm>
-          <a:prstGeom prst="rect">
-            <a:avLst/>
-          </a:prstGeom>
-          <a:noFill/>
-        </p:spPr>
-        <p:txBody>
-          <a:bodyPr wrap="square" lIns="0" tIns="0" rIns="0" bIns="0">
+            <a:off x="964692" y="3374136"/>
+            <a:ext cx="182880" cy="237744"/>
+          </a:xfrm>
+          <a:prstGeom prst="rect">
+            <a:avLst/>
+          </a:prstGeom>
+          <a:noFill/>
+        </p:spPr>
+        <p:txBody>
+          <a:bodyPr wrap="none" lIns="0" tIns="0" rIns="0" bIns="0">
             <a:spAutoFit/>
           </a:bodyPr>
           <a:lstStyle/>
           <a:p>
             <a:pPr algn="ctr"/>
             <a:r>
-              <a:rPr sz="1800" b="1">
-                <a:solidFill>
-                  <a:srgbClr val="FFFFFF"/>
-                </a:solidFill>
-                <a:latin typeface="Calibri"/>
+              <a:rPr sz="1300" b="1">
+                <a:solidFill>
+                  <a:srgbClr val="060F1B"/>
+                </a:solidFill>
+                <a:latin typeface="Aptos"/>
               </a:rPr>
               <a:t>✓</a:t>
             </a:r>
@@ -9568,33 +9637,33 @@
       </p:sp>
       <p:sp>
         <p:nvSpPr>
-          <p:cNvPr id="24" name="TextBox 23"/>
+          <p:cNvPr id="26" name="TextBox 25"/>
           <p:cNvSpPr txBox="1"/>
           <p:nvPr/>
         </p:nvSpPr>
         <p:spPr>
           <a:xfrm>
-            <a:off x="1508760" y="3364992"/>
-            <a:ext cx="1188720" cy="365760"/>
-          </a:xfrm>
-          <a:prstGeom prst="rect">
-            <a:avLst/>
-          </a:prstGeom>
-          <a:noFill/>
-        </p:spPr>
-        <p:txBody>
-          <a:bodyPr wrap="square" lIns="0" tIns="0" rIns="0" bIns="0">
+            <a:off x="1353312" y="3346704"/>
+            <a:ext cx="786384" cy="228600"/>
+          </a:xfrm>
+          <a:prstGeom prst="rect">
+            <a:avLst/>
+          </a:prstGeom>
+          <a:noFill/>
+        </p:spPr>
+        <p:txBody>
+          <a:bodyPr wrap="none" lIns="0" tIns="0" rIns="0" bIns="0">
             <a:spAutoFit/>
           </a:bodyPr>
           <a:lstStyle/>
           <a:p>
             <a:pPr algn="l"/>
             <a:r>
-              <a:rPr sz="1400" b="1">
-                <a:solidFill>
-                  <a:srgbClr val="1F6FEB"/>
-                </a:solidFill>
-                <a:latin typeface="Calibri"/>
+              <a:rPr sz="1000" b="1">
+                <a:solidFill>
+                  <a:srgbClr val="37D5DC"/>
+                </a:solidFill>
+                <a:latin typeface="Aptos"/>
               </a:rPr>
               <a:t>Phase 3</a:t>
             </a:r>
@@ -9603,96 +9672,95 @@
       </p:sp>
       <p:sp>
         <p:nvSpPr>
-          <p:cNvPr id="25" name="TextBox 24"/>
+          <p:cNvPr id="27" name="TextBox 26"/>
           <p:cNvSpPr txBox="1"/>
           <p:nvPr/>
         </p:nvSpPr>
         <p:spPr>
           <a:xfrm>
-            <a:off x="2743200" y="3346704"/>
-            <a:ext cx="8595360" cy="365760"/>
-          </a:xfrm>
-          <a:prstGeom prst="rect">
-            <a:avLst/>
-          </a:prstGeom>
-          <a:noFill/>
-        </p:spPr>
-        <p:txBody>
-          <a:bodyPr wrap="square" lIns="0" tIns="0" rIns="0" bIns="0">
+            <a:off x="2331720" y="3319272"/>
+            <a:ext cx="2057400" cy="256032"/>
+          </a:xfrm>
+          <a:prstGeom prst="rect">
+            <a:avLst/>
+          </a:prstGeom>
+          <a:noFill/>
+        </p:spPr>
+        <p:txBody>
+          <a:bodyPr wrap="none" lIns="0" tIns="0" rIns="0" bIns="0">
             <a:spAutoFit/>
           </a:bodyPr>
           <a:lstStyle/>
           <a:p>
             <a:pPr algn="l"/>
             <a:r>
-              <a:rPr sz="1600" b="1">
-                <a:solidFill>
-                  <a:srgbClr val="0F1F44"/>
-                </a:solidFill>
-                <a:latin typeface="Calibri"/>
-              </a:rPr>
-              <a:t>Real rPPG pipeline</a:t>
-            </a:r>
-          </a:p>
-        </p:txBody>
-      </p:sp>
-      <p:sp>
-        <p:nvSpPr>
-          <p:cNvPr id="26" name="TextBox 25"/>
+              <a:rPr sz="1450" b="1">
+                <a:solidFill>
+                  <a:srgbClr val="F1F7FF"/>
+                </a:solidFill>
+                <a:latin typeface="Aptos"/>
+              </a:rPr>
+              <a:t>Real rPPG core</a:t>
+            </a:r>
+          </a:p>
+        </p:txBody>
+      </p:sp>
+      <p:sp>
+        <p:nvSpPr>
+          <p:cNvPr id="28" name="TextBox 27"/>
           <p:cNvSpPr txBox="1"/>
           <p:nvPr/>
         </p:nvSpPr>
         <p:spPr>
           <a:xfrm>
-            <a:off x="2743200" y="3657600"/>
-            <a:ext cx="8595360" cy="274320"/>
-          </a:xfrm>
-          <a:prstGeom prst="rect">
-            <a:avLst/>
-          </a:prstGeom>
-          <a:noFill/>
-        </p:spPr>
-        <p:txBody>
-          <a:bodyPr wrap="square" lIns="0" tIns="0" rIns="0" bIns="0">
+            <a:off x="2331720" y="3584448"/>
+            <a:ext cx="4526280" cy="228600"/>
+          </a:xfrm>
+          <a:prstGeom prst="rect">
+            <a:avLst/>
+          </a:prstGeom>
+          <a:noFill/>
+        </p:spPr>
+        <p:txBody>
+          <a:bodyPr wrap="none" lIns="0" tIns="0" rIns="0" bIns="0">
             <a:spAutoFit/>
           </a:bodyPr>
           <a:lstStyle/>
           <a:p>
             <a:pPr algn="l"/>
             <a:r>
-              <a:rPr sz="1100" b="0">
-                <a:solidFill>
-                  <a:srgbClr val="55667A"/>
-                </a:solidFill>
-                <a:latin typeface="Calibri"/>
-              </a:rPr>
-              <a:t>Replaced the mock with the actual face detection · POS · HRV signal chain.</a:t>
-            </a:r>
-          </a:p>
-        </p:txBody>
-      </p:sp>
-      <p:sp>
-        <p:nvSpPr>
-          <p:cNvPr id="27" name="Rounded Rectangle 26"/>
-          <p:cNvSpPr/>
-          <p:nvPr/>
-        </p:nvSpPr>
-        <p:spPr>
-          <a:xfrm>
-            <a:off x="685800" y="4160520"/>
-            <a:ext cx="10789920" cy="777240"/>
+              <a:rPr sz="880" b="0">
+                <a:solidFill>
+                  <a:srgbClr val="97A8BE"/>
+                </a:solidFill>
+                <a:latin typeface="Aptos"/>
+              </a:rPr>
+              <a:t>FaceMesh → ROI → RGB time series → POS
+filter/FFT → BPM, HRV, stress.</a:t>
+            </a:r>
+          </a:p>
+        </p:txBody>
+      </p:sp>
+      <p:sp>
+        <p:nvSpPr>
+          <p:cNvPr id="29" name="Rounded Rectangle 28"/>
+          <p:cNvSpPr/>
+          <p:nvPr/>
+        </p:nvSpPr>
+        <p:spPr>
+          <a:xfrm>
+            <a:off x="786384" y="3913631"/>
+            <a:ext cx="6903720" cy="658368"/>
           </a:xfrm>
           <a:prstGeom prst="roundRect">
-            <a:avLst>
-              <a:gd name="adj" fmla="val 18000"/>
-            </a:avLst>
+            <a:avLst/>
           </a:prstGeom>
           <a:solidFill>
-            <a:srgbClr val="F6F8FB"/>
+            <a:srgbClr val="0E1E2F"/>
           </a:solidFill>
-          <a:ln w="12700">
+          <a:ln w="11430">
             <a:solidFill>
-              <a:srgbClr val="1F6FEB"/>
+              <a:srgbClr val="244869"/>
             </a:solidFill>
           </a:ln>
         </p:spPr>
@@ -9721,20 +9789,20 @@
       </p:sp>
       <p:sp>
         <p:nvSpPr>
-          <p:cNvPr id="28" name="Oval 27"/>
-          <p:cNvSpPr/>
-          <p:nvPr/>
-        </p:nvSpPr>
-        <p:spPr>
-          <a:xfrm>
-            <a:off x="914400" y="4352544"/>
-            <a:ext cx="384048" cy="384048"/>
+          <p:cNvPr id="30" name="Oval 29"/>
+          <p:cNvSpPr/>
+          <p:nvPr/>
+        </p:nvSpPr>
+        <p:spPr>
+          <a:xfrm>
+            <a:off x="905256" y="4087368"/>
+            <a:ext cx="301752" cy="301752"/>
           </a:xfrm>
           <a:prstGeom prst="ellipse">
             <a:avLst/>
           </a:prstGeom>
           <a:solidFill>
-            <a:srgbClr val="1E884F"/>
+            <a:srgbClr val="26CB7C"/>
           </a:solidFill>
           <a:ln>
             <a:noFill/>
@@ -9765,33 +9833,33 @@
       </p:sp>
       <p:sp>
         <p:nvSpPr>
-          <p:cNvPr id="29" name="TextBox 28"/>
+          <p:cNvPr id="31" name="TextBox 30"/>
           <p:cNvSpPr txBox="1"/>
           <p:nvPr/>
         </p:nvSpPr>
         <p:spPr>
           <a:xfrm>
-            <a:off x="914400" y="4361688"/>
-            <a:ext cx="384048" cy="384048"/>
-          </a:xfrm>
-          <a:prstGeom prst="rect">
-            <a:avLst/>
-          </a:prstGeom>
-          <a:noFill/>
-        </p:spPr>
-        <p:txBody>
-          <a:bodyPr wrap="square" lIns="0" tIns="0" rIns="0" bIns="0">
+            <a:off x="964692" y="4087368"/>
+            <a:ext cx="182880" cy="237744"/>
+          </a:xfrm>
+          <a:prstGeom prst="rect">
+            <a:avLst/>
+          </a:prstGeom>
+          <a:noFill/>
+        </p:spPr>
+        <p:txBody>
+          <a:bodyPr wrap="none" lIns="0" tIns="0" rIns="0" bIns="0">
             <a:spAutoFit/>
           </a:bodyPr>
           <a:lstStyle/>
           <a:p>
             <a:pPr algn="ctr"/>
             <a:r>
-              <a:rPr sz="1800" b="1">
-                <a:solidFill>
-                  <a:srgbClr val="FFFFFF"/>
-                </a:solidFill>
-                <a:latin typeface="Calibri"/>
+              <a:rPr sz="1300" b="1">
+                <a:solidFill>
+                  <a:srgbClr val="060F1B"/>
+                </a:solidFill>
+                <a:latin typeface="Aptos"/>
               </a:rPr>
               <a:t>✓</a:t>
             </a:r>
@@ -9800,33 +9868,33 @@
       </p:sp>
       <p:sp>
         <p:nvSpPr>
-          <p:cNvPr id="30" name="TextBox 29"/>
+          <p:cNvPr id="32" name="TextBox 31"/>
           <p:cNvSpPr txBox="1"/>
           <p:nvPr/>
         </p:nvSpPr>
         <p:spPr>
           <a:xfrm>
-            <a:off x="1508760" y="4325112"/>
-            <a:ext cx="1188720" cy="365760"/>
-          </a:xfrm>
-          <a:prstGeom prst="rect">
-            <a:avLst/>
-          </a:prstGeom>
-          <a:noFill/>
-        </p:spPr>
-        <p:txBody>
-          <a:bodyPr wrap="square" lIns="0" tIns="0" rIns="0" bIns="0">
+            <a:off x="1353312" y="4059935"/>
+            <a:ext cx="786384" cy="228600"/>
+          </a:xfrm>
+          <a:prstGeom prst="rect">
+            <a:avLst/>
+          </a:prstGeom>
+          <a:noFill/>
+        </p:spPr>
+        <p:txBody>
+          <a:bodyPr wrap="none" lIns="0" tIns="0" rIns="0" bIns="0">
             <a:spAutoFit/>
           </a:bodyPr>
           <a:lstStyle/>
           <a:p>
             <a:pPr algn="l"/>
             <a:r>
-              <a:rPr sz="1400" b="1">
-                <a:solidFill>
-                  <a:srgbClr val="1F6FEB"/>
-                </a:solidFill>
-                <a:latin typeface="Calibri"/>
+              <a:rPr sz="1000" b="1">
+                <a:solidFill>
+                  <a:srgbClr val="26CB7C"/>
+                </a:solidFill>
+                <a:latin typeface="Aptos"/>
               </a:rPr>
               <a:t>Phase 4</a:t>
             </a:r>
@@ -9835,96 +9903,95 @@
       </p:sp>
       <p:sp>
         <p:nvSpPr>
-          <p:cNvPr id="31" name="TextBox 30"/>
+          <p:cNvPr id="33" name="TextBox 32"/>
           <p:cNvSpPr txBox="1"/>
           <p:nvPr/>
         </p:nvSpPr>
         <p:spPr>
           <a:xfrm>
-            <a:off x="2743200" y="4306824"/>
-            <a:ext cx="8595360" cy="365760"/>
-          </a:xfrm>
-          <a:prstGeom prst="rect">
-            <a:avLst/>
-          </a:prstGeom>
-          <a:noFill/>
-        </p:spPr>
-        <p:txBody>
-          <a:bodyPr wrap="square" lIns="0" tIns="0" rIns="0" bIns="0">
+            <a:off x="2331720" y="4032503"/>
+            <a:ext cx="2057400" cy="256032"/>
+          </a:xfrm>
+          <a:prstGeom prst="rect">
+            <a:avLst/>
+          </a:prstGeom>
+          <a:noFill/>
+        </p:spPr>
+        <p:txBody>
+          <a:bodyPr wrap="none" lIns="0" tIns="0" rIns="0" bIns="0">
             <a:spAutoFit/>
           </a:bodyPr>
           <a:lstStyle/>
           <a:p>
             <a:pPr algn="l"/>
             <a:r>
-              <a:rPr sz="1600" b="1">
-                <a:solidFill>
-                  <a:srgbClr val="0F1F44"/>
-                </a:solidFill>
-                <a:latin typeface="Calibri"/>
-              </a:rPr>
-              <a:t>Docker + Cloudflare Tunnel deployment</a:t>
-            </a:r>
-          </a:p>
-        </p:txBody>
-      </p:sp>
-      <p:sp>
-        <p:nvSpPr>
-          <p:cNvPr id="32" name="TextBox 31"/>
+              <a:rPr sz="1450" b="1">
+                <a:solidFill>
+                  <a:srgbClr val="F1F7FF"/>
+                </a:solidFill>
+                <a:latin typeface="Aptos"/>
+              </a:rPr>
+              <a:t>Live deployment</a:t>
+            </a:r>
+          </a:p>
+        </p:txBody>
+      </p:sp>
+      <p:sp>
+        <p:nvSpPr>
+          <p:cNvPr id="34" name="TextBox 33"/>
           <p:cNvSpPr txBox="1"/>
           <p:nvPr/>
         </p:nvSpPr>
         <p:spPr>
           <a:xfrm>
-            <a:off x="2743200" y="4617720"/>
-            <a:ext cx="8595360" cy="274320"/>
-          </a:xfrm>
-          <a:prstGeom prst="rect">
-            <a:avLst/>
-          </a:prstGeom>
-          <a:noFill/>
-        </p:spPr>
-        <p:txBody>
-          <a:bodyPr wrap="square" lIns="0" tIns="0" rIns="0" bIns="0">
+            <a:off x="2331720" y="4297679"/>
+            <a:ext cx="4526280" cy="228600"/>
+          </a:xfrm>
+          <a:prstGeom prst="rect">
+            <a:avLst/>
+          </a:prstGeom>
+          <a:noFill/>
+        </p:spPr>
+        <p:txBody>
+          <a:bodyPr wrap="none" lIns="0" tIns="0" rIns="0" bIns="0">
             <a:spAutoFit/>
           </a:bodyPr>
           <a:lstStyle/>
           <a:p>
             <a:pPr algn="l"/>
             <a:r>
-              <a:rPr sz="1100" b="0">
-                <a:solidFill>
-                  <a:srgbClr val="55667A"/>
-                </a:solidFill>
-                <a:latin typeface="Calibri"/>
-              </a:rPr>
-              <a:t>Three-container stack on the homelab, live at vitalscan.bkre8tive.com.</a:t>
-            </a:r>
-          </a:p>
-        </p:txBody>
-      </p:sp>
-      <p:sp>
-        <p:nvSpPr>
-          <p:cNvPr id="33" name="Rounded Rectangle 32"/>
-          <p:cNvSpPr/>
-          <p:nvPr/>
-        </p:nvSpPr>
-        <p:spPr>
-          <a:xfrm>
-            <a:off x="685800" y="5120640"/>
-            <a:ext cx="10789920" cy="777240"/>
+              <a:rPr sz="880" b="0">
+                <a:solidFill>
+                  <a:srgbClr val="97A8BE"/>
+                </a:solidFill>
+                <a:latin typeface="Aptos"/>
+              </a:rPr>
+              <a:t>Docker + Cloudflare Tunnel on homelab;
+TLS at edge, no open home ports.</a:t>
+            </a:r>
+          </a:p>
+        </p:txBody>
+      </p:sp>
+      <p:sp>
+        <p:nvSpPr>
+          <p:cNvPr id="35" name="Rounded Rectangle 34"/>
+          <p:cNvSpPr/>
+          <p:nvPr/>
+        </p:nvSpPr>
+        <p:spPr>
+          <a:xfrm>
+            <a:off x="786384" y="4626864"/>
+            <a:ext cx="6903720" cy="658368"/>
           </a:xfrm>
           <a:prstGeom prst="roundRect">
-            <a:avLst>
-              <a:gd name="adj" fmla="val 18000"/>
-            </a:avLst>
+            <a:avLst/>
           </a:prstGeom>
           <a:solidFill>
-            <a:srgbClr val="F6F8FB"/>
+            <a:srgbClr val="0E1E2F"/>
           </a:solidFill>
-          <a:ln w="12700">
+          <a:ln w="11430">
             <a:solidFill>
-              <a:srgbClr val="1F6FEB"/>
+              <a:srgbClr val="244869"/>
             </a:solidFill>
           </a:ln>
         </p:spPr>
@@ -9953,20 +10020,20 @@
       </p:sp>
       <p:sp>
         <p:nvSpPr>
-          <p:cNvPr id="34" name="Oval 33"/>
-          <p:cNvSpPr/>
-          <p:nvPr/>
-        </p:nvSpPr>
-        <p:spPr>
-          <a:xfrm>
-            <a:off x="914400" y="5312664"/>
-            <a:ext cx="384048" cy="384048"/>
+          <p:cNvPr id="36" name="Oval 35"/>
+          <p:cNvSpPr/>
+          <p:nvPr/>
+        </p:nvSpPr>
+        <p:spPr>
+          <a:xfrm>
+            <a:off x="905256" y="4800600"/>
+            <a:ext cx="301752" cy="301752"/>
           </a:xfrm>
           <a:prstGeom prst="ellipse">
             <a:avLst/>
           </a:prstGeom>
           <a:solidFill>
-            <a:srgbClr val="1E884F"/>
+            <a:srgbClr val="2F80ED"/>
           </a:solidFill>
           <a:ln>
             <a:noFill/>
@@ -9997,33 +10064,33 @@
       </p:sp>
       <p:sp>
         <p:nvSpPr>
-          <p:cNvPr id="35" name="TextBox 34"/>
+          <p:cNvPr id="37" name="TextBox 36"/>
           <p:cNvSpPr txBox="1"/>
           <p:nvPr/>
         </p:nvSpPr>
         <p:spPr>
           <a:xfrm>
-            <a:off x="914400" y="5321808"/>
-            <a:ext cx="384048" cy="384048"/>
-          </a:xfrm>
-          <a:prstGeom prst="rect">
-            <a:avLst/>
-          </a:prstGeom>
-          <a:noFill/>
-        </p:spPr>
-        <p:txBody>
-          <a:bodyPr wrap="square" lIns="0" tIns="0" rIns="0" bIns="0">
+            <a:off x="964692" y="4800600"/>
+            <a:ext cx="182880" cy="237744"/>
+          </a:xfrm>
+          <a:prstGeom prst="rect">
+            <a:avLst/>
+          </a:prstGeom>
+          <a:noFill/>
+        </p:spPr>
+        <p:txBody>
+          <a:bodyPr wrap="none" lIns="0" tIns="0" rIns="0" bIns="0">
             <a:spAutoFit/>
           </a:bodyPr>
           <a:lstStyle/>
           <a:p>
             <a:pPr algn="ctr"/>
             <a:r>
-              <a:rPr sz="1800" b="1">
-                <a:solidFill>
-                  <a:srgbClr val="FFFFFF"/>
-                </a:solidFill>
-                <a:latin typeface="Calibri"/>
+              <a:rPr sz="1300" b="1">
+                <a:solidFill>
+                  <a:srgbClr val="060F1B"/>
+                </a:solidFill>
+                <a:latin typeface="Aptos"/>
               </a:rPr>
               <a:t>✓</a:t>
             </a:r>
@@ -10032,33 +10099,33 @@
       </p:sp>
       <p:sp>
         <p:nvSpPr>
-          <p:cNvPr id="36" name="TextBox 35"/>
+          <p:cNvPr id="38" name="TextBox 37"/>
           <p:cNvSpPr txBox="1"/>
           <p:nvPr/>
         </p:nvSpPr>
         <p:spPr>
           <a:xfrm>
-            <a:off x="1508760" y="5285232"/>
-            <a:ext cx="1188720" cy="365760"/>
-          </a:xfrm>
-          <a:prstGeom prst="rect">
-            <a:avLst/>
-          </a:prstGeom>
-          <a:noFill/>
-        </p:spPr>
-        <p:txBody>
-          <a:bodyPr wrap="square" lIns="0" tIns="0" rIns="0" bIns="0">
+            <a:off x="1353312" y="4773168"/>
+            <a:ext cx="786384" cy="228600"/>
+          </a:xfrm>
+          <a:prstGeom prst="rect">
+            <a:avLst/>
+          </a:prstGeom>
+          <a:noFill/>
+        </p:spPr>
+        <p:txBody>
+          <a:bodyPr wrap="none" lIns="0" tIns="0" rIns="0" bIns="0">
             <a:spAutoFit/>
           </a:bodyPr>
           <a:lstStyle/>
           <a:p>
             <a:pPr algn="l"/>
             <a:r>
-              <a:rPr sz="1400" b="1">
-                <a:solidFill>
-                  <a:srgbClr val="1F6FEB"/>
-                </a:solidFill>
-                <a:latin typeface="Calibri"/>
+              <a:rPr sz="1000" b="1">
+                <a:solidFill>
+                  <a:srgbClr val="2F80ED"/>
+                </a:solidFill>
+                <a:latin typeface="Aptos"/>
               </a:rPr>
               <a:t>Phase 5</a:t>
             </a:r>
@@ -10067,70 +10134,735 @@
       </p:sp>
       <p:sp>
         <p:nvSpPr>
-          <p:cNvPr id="37" name="TextBox 36"/>
+          <p:cNvPr id="39" name="TextBox 38"/>
           <p:cNvSpPr txBox="1"/>
           <p:nvPr/>
         </p:nvSpPr>
         <p:spPr>
           <a:xfrm>
-            <a:off x="2743200" y="5266944"/>
-            <a:ext cx="8595360" cy="365760"/>
-          </a:xfrm>
-          <a:prstGeom prst="rect">
-            <a:avLst/>
-          </a:prstGeom>
-          <a:noFill/>
-        </p:spPr>
-        <p:txBody>
-          <a:bodyPr wrap="square" lIns="0" tIns="0" rIns="0" bIns="0">
+            <a:off x="2331720" y="4745736"/>
+            <a:ext cx="2057400" cy="256032"/>
+          </a:xfrm>
+          <a:prstGeom prst="rect">
+            <a:avLst/>
+          </a:prstGeom>
+          <a:noFill/>
+        </p:spPr>
+        <p:txBody>
+          <a:bodyPr wrap="none" lIns="0" tIns="0" rIns="0" bIns="0">
             <a:spAutoFit/>
           </a:bodyPr>
           <a:lstStyle/>
           <a:p>
             <a:pPr algn="l"/>
             <a:r>
-              <a:rPr sz="1600" b="1">
-                <a:solidFill>
-                  <a:srgbClr val="0F1F44"/>
-                </a:solidFill>
-                <a:latin typeface="Calibri"/>
-              </a:rPr>
-              <a:t>Browser webcam capture</a:t>
-            </a:r>
-          </a:p>
-        </p:txBody>
-      </p:sp>
-      <p:sp>
-        <p:nvSpPr>
-          <p:cNvPr id="38" name="TextBox 37"/>
+              <a:rPr sz="1450" b="1">
+                <a:solidFill>
+                  <a:srgbClr val="F1F7FF"/>
+                </a:solidFill>
+                <a:latin typeface="Aptos"/>
+              </a:rPr>
+              <a:t>Browser capture</a:t>
+            </a:r>
+          </a:p>
+        </p:txBody>
+      </p:sp>
+      <p:sp>
+        <p:nvSpPr>
+          <p:cNvPr id="40" name="TextBox 39"/>
           <p:cNvSpPr txBox="1"/>
           <p:nvPr/>
         </p:nvSpPr>
         <p:spPr>
           <a:xfrm>
-            <a:off x="2743200" y="5577840"/>
-            <a:ext cx="8595360" cy="274320"/>
-          </a:xfrm>
-          <a:prstGeom prst="rect">
-            <a:avLst/>
-          </a:prstGeom>
-          <a:noFill/>
-        </p:spPr>
-        <p:txBody>
-          <a:bodyPr wrap="square" lIns="0" tIns="0" rIns="0" bIns="0">
+            <a:off x="2331720" y="5010912"/>
+            <a:ext cx="4526280" cy="228600"/>
+          </a:xfrm>
+          <a:prstGeom prst="rect">
+            <a:avLst/>
+          </a:prstGeom>
+          <a:noFill/>
+        </p:spPr>
+        <p:txBody>
+          <a:bodyPr wrap="none" lIns="0" tIns="0" rIns="0" bIns="0">
             <a:spAutoFit/>
           </a:bodyPr>
           <a:lstStyle/>
           <a:p>
             <a:pPr algn="l"/>
             <a:r>
-              <a:rPr sz="1100" b="0">
-                <a:solidFill>
-                  <a:srgbClr val="55667A"/>
-                </a:solidFill>
-                <a:latin typeface="Calibri"/>
-              </a:rPr>
-              <a:t>In-browser 30-second capture using getUserMedia and MediaRecorder.</a:t>
+              <a:rPr sz="880" b="0">
+                <a:solidFill>
+                  <a:srgbClr val="97A8BE"/>
+                </a:solidFill>
+                <a:latin typeface="Aptos"/>
+              </a:rPr>
+              <a:t>30-second in-browser recording with
+getUserMedia + MediaRecorder.</a:t>
+            </a:r>
+          </a:p>
+        </p:txBody>
+      </p:sp>
+      <p:sp>
+        <p:nvSpPr>
+          <p:cNvPr id="41" name="Rounded Rectangle 40"/>
+          <p:cNvSpPr/>
+          <p:nvPr/>
+        </p:nvSpPr>
+        <p:spPr>
+          <a:xfrm>
+            <a:off x="7973568" y="1572768"/>
+            <a:ext cx="2953512" cy="3273552"/>
+          </a:xfrm>
+          <a:prstGeom prst="roundRect">
+            <a:avLst/>
+          </a:prstGeom>
+          <a:solidFill>
+            <a:srgbClr val="0A1826"/>
+          </a:solidFill>
+          <a:ln w="12700">
+            <a:solidFill>
+              <a:srgbClr val="214B62"/>
+            </a:solidFill>
+          </a:ln>
+        </p:spPr>
+        <p:style>
+          <a:lnRef idx="1">
+            <a:schemeClr val="accent1"/>
+          </a:lnRef>
+          <a:fillRef idx="3">
+            <a:schemeClr val="accent1"/>
+          </a:fillRef>
+          <a:effectRef idx="2">
+            <a:schemeClr val="accent1"/>
+          </a:effectRef>
+          <a:fontRef idx="minor">
+            <a:schemeClr val="lt1"/>
+          </a:fontRef>
+        </p:style>
+        <p:txBody>
+          <a:bodyPr rtlCol="0" anchor="ctr"/>
+          <a:lstStyle/>
+          <a:p>
+            <a:pPr algn="ctr"/>
+            <a:endParaRPr/>
+          </a:p>
+        </p:txBody>
+      </p:sp>
+      <p:sp>
+        <p:nvSpPr>
+          <p:cNvPr id="42" name="TextBox 41"/>
+          <p:cNvSpPr txBox="1"/>
+          <p:nvPr/>
+        </p:nvSpPr>
+        <p:spPr>
+          <a:xfrm>
+            <a:off x="8183879" y="1773936"/>
+            <a:ext cx="1463040" cy="201168"/>
+          </a:xfrm>
+          <a:prstGeom prst="rect">
+            <a:avLst/>
+          </a:prstGeom>
+          <a:noFill/>
+        </p:spPr>
+        <p:txBody>
+          <a:bodyPr wrap="none" lIns="0" tIns="0" rIns="0" bIns="0">
+            <a:spAutoFit/>
+          </a:bodyPr>
+          <a:lstStyle/>
+          <a:p>
+            <a:pPr algn="l"/>
+            <a:r>
+              <a:rPr sz="850" b="1">
+                <a:solidFill>
+                  <a:srgbClr val="26CB7C"/>
+                </a:solidFill>
+                <a:latin typeface="Aptos"/>
+              </a:rPr>
+              <a:t>WHAT THIS PROVES</a:t>
+            </a:r>
+          </a:p>
+        </p:txBody>
+      </p:sp>
+      <p:sp>
+        <p:nvSpPr>
+          <p:cNvPr id="43" name="TextBox 42"/>
+          <p:cNvSpPr txBox="1"/>
+          <p:nvPr/>
+        </p:nvSpPr>
+        <p:spPr>
+          <a:xfrm>
+            <a:off x="8211312" y="2103120"/>
+            <a:ext cx="777240" cy="164592"/>
+          </a:xfrm>
+          <a:prstGeom prst="rect">
+            <a:avLst/>
+          </a:prstGeom>
+          <a:noFill/>
+        </p:spPr>
+        <p:txBody>
+          <a:bodyPr wrap="none" lIns="0" tIns="0" rIns="0" bIns="0">
+            <a:spAutoFit/>
+          </a:bodyPr>
+          <a:lstStyle/>
+          <a:p>
+            <a:pPr algn="l"/>
+            <a:r>
+              <a:rPr sz="880" b="1">
+                <a:solidFill>
+                  <a:srgbClr val="F5C444"/>
+                </a:solidFill>
+                <a:latin typeface="Aptos Mono"/>
+              </a:rPr>
+              <a:t>frontend/</a:t>
+            </a:r>
+          </a:p>
+        </p:txBody>
+      </p:sp>
+      <p:sp>
+        <p:nvSpPr>
+          <p:cNvPr id="44" name="TextBox 43"/>
+          <p:cNvSpPr txBox="1"/>
+          <p:nvPr/>
+        </p:nvSpPr>
+        <p:spPr>
+          <a:xfrm>
+            <a:off x="9006840" y="2103120"/>
+            <a:ext cx="1691640" cy="164592"/>
+          </a:xfrm>
+          <a:prstGeom prst="rect">
+            <a:avLst/>
+          </a:prstGeom>
+          <a:noFill/>
+        </p:spPr>
+        <p:txBody>
+          <a:bodyPr wrap="none" lIns="0" tIns="0" rIns="0" bIns="0">
+            <a:spAutoFit/>
+          </a:bodyPr>
+          <a:lstStyle/>
+          <a:p>
+            <a:pPr algn="l"/>
+            <a:r>
+              <a:rPr sz="790" b="0">
+                <a:solidFill>
+                  <a:srgbClr val="97A8BE"/>
+                </a:solidFill>
+                <a:latin typeface="Aptos"/>
+              </a:rPr>
+              <a:t>React UI + webcam dashboard</a:t>
+            </a:r>
+          </a:p>
+        </p:txBody>
+      </p:sp>
+      <p:sp>
+        <p:nvSpPr>
+          <p:cNvPr id="45" name="TextBox 44"/>
+          <p:cNvSpPr txBox="1"/>
+          <p:nvPr/>
+        </p:nvSpPr>
+        <p:spPr>
+          <a:xfrm>
+            <a:off x="8211312" y="2542032"/>
+            <a:ext cx="777240" cy="164592"/>
+          </a:xfrm>
+          <a:prstGeom prst="rect">
+            <a:avLst/>
+          </a:prstGeom>
+          <a:noFill/>
+        </p:spPr>
+        <p:txBody>
+          <a:bodyPr wrap="none" lIns="0" tIns="0" rIns="0" bIns="0">
+            <a:spAutoFit/>
+          </a:bodyPr>
+          <a:lstStyle/>
+          <a:p>
+            <a:pPr algn="l"/>
+            <a:r>
+              <a:rPr sz="880" b="1">
+                <a:solidFill>
+                  <a:srgbClr val="F5C444"/>
+                </a:solidFill>
+                <a:latin typeface="Aptos Mono"/>
+              </a:rPr>
+              <a:t>backend/</a:t>
+            </a:r>
+          </a:p>
+        </p:txBody>
+      </p:sp>
+      <p:sp>
+        <p:nvSpPr>
+          <p:cNvPr id="46" name="TextBox 45"/>
+          <p:cNvSpPr txBox="1"/>
+          <p:nvPr/>
+        </p:nvSpPr>
+        <p:spPr>
+          <a:xfrm>
+            <a:off x="9006840" y="2542032"/>
+            <a:ext cx="1691640" cy="164592"/>
+          </a:xfrm>
+          <a:prstGeom prst="rect">
+            <a:avLst/>
+          </a:prstGeom>
+          <a:noFill/>
+        </p:spPr>
+        <p:txBody>
+          <a:bodyPr wrap="none" lIns="0" tIns="0" rIns="0" bIns="0">
+            <a:spAutoFit/>
+          </a:bodyPr>
+          <a:lstStyle/>
+          <a:p>
+            <a:pPr algn="l"/>
+            <a:r>
+              <a:rPr sz="790" b="0">
+                <a:solidFill>
+                  <a:srgbClr val="97A8BE"/>
+                </a:solidFill>
+                <a:latin typeface="Aptos"/>
+              </a:rPr>
+              <a:t>main.py + FastAPI + rppg/</a:t>
+            </a:r>
+          </a:p>
+        </p:txBody>
+      </p:sp>
+      <p:sp>
+        <p:nvSpPr>
+          <p:cNvPr id="47" name="TextBox 46"/>
+          <p:cNvSpPr txBox="1"/>
+          <p:nvPr/>
+        </p:nvSpPr>
+        <p:spPr>
+          <a:xfrm>
+            <a:off x="8211312" y="2980944"/>
+            <a:ext cx="777240" cy="164592"/>
+          </a:xfrm>
+          <a:prstGeom prst="rect">
+            <a:avLst/>
+          </a:prstGeom>
+          <a:noFill/>
+        </p:spPr>
+        <p:txBody>
+          <a:bodyPr wrap="none" lIns="0" tIns="0" rIns="0" bIns="0">
+            <a:spAutoFit/>
+          </a:bodyPr>
+          <a:lstStyle/>
+          <a:p>
+            <a:pPr algn="l"/>
+            <a:r>
+              <a:rPr sz="880" b="1">
+                <a:solidFill>
+                  <a:srgbClr val="F5C444"/>
+                </a:solidFill>
+                <a:latin typeface="Aptos Mono"/>
+              </a:rPr>
+              <a:t>data/</a:t>
+            </a:r>
+          </a:p>
+        </p:txBody>
+      </p:sp>
+      <p:sp>
+        <p:nvSpPr>
+          <p:cNvPr id="48" name="TextBox 47"/>
+          <p:cNvSpPr txBox="1"/>
+          <p:nvPr/>
+        </p:nvSpPr>
+        <p:spPr>
+          <a:xfrm>
+            <a:off x="9006840" y="2980944"/>
+            <a:ext cx="1691640" cy="164592"/>
+          </a:xfrm>
+          <a:prstGeom prst="rect">
+            <a:avLst/>
+          </a:prstGeom>
+          <a:noFill/>
+        </p:spPr>
+        <p:txBody>
+          <a:bodyPr wrap="none" lIns="0" tIns="0" rIns="0" bIns="0">
+            <a:spAutoFit/>
+          </a:bodyPr>
+          <a:lstStyle/>
+          <a:p>
+            <a:pPr algn="l"/>
+            <a:r>
+              <a:rPr sz="790" b="0">
+                <a:solidFill>
+                  <a:srgbClr val="97A8BE"/>
+                </a:solidFill>
+                <a:latin typeface="Aptos"/>
+              </a:rPr>
+              <a:t>UBFC + SCAMPS evaluation files</a:t>
+            </a:r>
+          </a:p>
+        </p:txBody>
+      </p:sp>
+      <p:sp>
+        <p:nvSpPr>
+          <p:cNvPr id="49" name="TextBox 48"/>
+          <p:cNvSpPr txBox="1"/>
+          <p:nvPr/>
+        </p:nvSpPr>
+        <p:spPr>
+          <a:xfrm>
+            <a:off x="8211312" y="3419856"/>
+            <a:ext cx="777240" cy="164592"/>
+          </a:xfrm>
+          <a:prstGeom prst="rect">
+            <a:avLst/>
+          </a:prstGeom>
+          <a:noFill/>
+        </p:spPr>
+        <p:txBody>
+          <a:bodyPr wrap="none" lIns="0" tIns="0" rIns="0" bIns="0">
+            <a:spAutoFit/>
+          </a:bodyPr>
+          <a:lstStyle/>
+          <a:p>
+            <a:pPr algn="l"/>
+            <a:r>
+              <a:rPr sz="880" b="1">
+                <a:solidFill>
+                  <a:srgbClr val="F5C444"/>
+                </a:solidFill>
+                <a:latin typeface="Aptos Mono"/>
+              </a:rPr>
+              <a:t>docs/</a:t>
+            </a:r>
+          </a:p>
+        </p:txBody>
+      </p:sp>
+      <p:sp>
+        <p:nvSpPr>
+          <p:cNvPr id="50" name="TextBox 49"/>
+          <p:cNvSpPr txBox="1"/>
+          <p:nvPr/>
+        </p:nvSpPr>
+        <p:spPr>
+          <a:xfrm>
+            <a:off x="9006840" y="3419856"/>
+            <a:ext cx="1691640" cy="164592"/>
+          </a:xfrm>
+          <a:prstGeom prst="rect">
+            <a:avLst/>
+          </a:prstGeom>
+          <a:noFill/>
+        </p:spPr>
+        <p:txBody>
+          <a:bodyPr wrap="none" lIns="0" tIns="0" rIns="0" bIns="0">
+            <a:spAutoFit/>
+          </a:bodyPr>
+          <a:lstStyle/>
+          <a:p>
+            <a:pPr algn="l"/>
+            <a:r>
+              <a:rPr sz="790" b="0">
+                <a:solidFill>
+                  <a:srgbClr val="97A8BE"/>
+                </a:solidFill>
+                <a:latin typeface="Aptos"/>
+              </a:rPr>
+              <a:t>writeup + evaluation results</a:t>
+            </a:r>
+          </a:p>
+        </p:txBody>
+      </p:sp>
+      <p:sp>
+        <p:nvSpPr>
+          <p:cNvPr id="51" name="TextBox 50"/>
+          <p:cNvSpPr txBox="1"/>
+          <p:nvPr/>
+        </p:nvSpPr>
+        <p:spPr>
+          <a:xfrm>
+            <a:off x="8211312" y="3858768"/>
+            <a:ext cx="777240" cy="164592"/>
+          </a:xfrm>
+          <a:prstGeom prst="rect">
+            <a:avLst/>
+          </a:prstGeom>
+          <a:noFill/>
+        </p:spPr>
+        <p:txBody>
+          <a:bodyPr wrap="none" lIns="0" tIns="0" rIns="0" bIns="0">
+            <a:spAutoFit/>
+          </a:bodyPr>
+          <a:lstStyle/>
+          <a:p>
+            <a:pPr algn="l"/>
+            <a:r>
+              <a:rPr sz="880" b="1">
+                <a:solidFill>
+                  <a:srgbClr val="F5C444"/>
+                </a:solidFill>
+                <a:latin typeface="Aptos Mono"/>
+              </a:rPr>
+              <a:t>deploy/</a:t>
+            </a:r>
+          </a:p>
+        </p:txBody>
+      </p:sp>
+      <p:sp>
+        <p:nvSpPr>
+          <p:cNvPr id="52" name="TextBox 51"/>
+          <p:cNvSpPr txBox="1"/>
+          <p:nvPr/>
+        </p:nvSpPr>
+        <p:spPr>
+          <a:xfrm>
+            <a:off x="9006840" y="3858768"/>
+            <a:ext cx="1691640" cy="164592"/>
+          </a:xfrm>
+          <a:prstGeom prst="rect">
+            <a:avLst/>
+          </a:prstGeom>
+          <a:noFill/>
+        </p:spPr>
+        <p:txBody>
+          <a:bodyPr wrap="none" lIns="0" tIns="0" rIns="0" bIns="0">
+            <a:spAutoFit/>
+          </a:bodyPr>
+          <a:lstStyle/>
+          <a:p>
+            <a:pPr algn="l"/>
+            <a:r>
+              <a:rPr sz="790" b="0">
+                <a:solidFill>
+                  <a:srgbClr val="97A8BE"/>
+                </a:solidFill>
+                <a:latin typeface="Aptos"/>
+              </a:rPr>
+              <a:t>Docker / tunnel deployment</a:t>
+            </a:r>
+          </a:p>
+        </p:txBody>
+      </p:sp>
+      <p:sp>
+        <p:nvSpPr>
+          <p:cNvPr id="53" name="Rounded Rectangle 52"/>
+          <p:cNvSpPr/>
+          <p:nvPr/>
+        </p:nvSpPr>
+        <p:spPr>
+          <a:xfrm>
+            <a:off x="8183879" y="4434840"/>
+            <a:ext cx="2514600" cy="713232"/>
+          </a:xfrm>
+          <a:prstGeom prst="roundRect">
+            <a:avLst/>
+          </a:prstGeom>
+          <a:solidFill>
+            <a:srgbClr val="0B252F"/>
+          </a:solidFill>
+          <a:ln w="10160">
+            <a:solidFill>
+              <a:srgbClr val="297077"/>
+            </a:solidFill>
+          </a:ln>
+        </p:spPr>
+        <p:style>
+          <a:lnRef idx="1">
+            <a:schemeClr val="accent1"/>
+          </a:lnRef>
+          <a:fillRef idx="3">
+            <a:schemeClr val="accent1"/>
+          </a:fillRef>
+          <a:effectRef idx="2">
+            <a:schemeClr val="accent1"/>
+          </a:effectRef>
+          <a:fontRef idx="minor">
+            <a:schemeClr val="lt1"/>
+          </a:fontRef>
+        </p:style>
+        <p:txBody>
+          <a:bodyPr rtlCol="0" anchor="ctr"/>
+          <a:lstStyle/>
+          <a:p>
+            <a:pPr algn="ctr"/>
+            <a:endParaRPr/>
+          </a:p>
+        </p:txBody>
+      </p:sp>
+      <p:sp>
+        <p:nvSpPr>
+          <p:cNvPr id="54" name="TextBox 53"/>
+          <p:cNvSpPr txBox="1"/>
+          <p:nvPr/>
+        </p:nvSpPr>
+        <p:spPr>
+          <a:xfrm>
+            <a:off x="8339327" y="4572000"/>
+            <a:ext cx="594360" cy="146304"/>
+          </a:xfrm>
+          <a:prstGeom prst="rect">
+            <a:avLst/>
+          </a:prstGeom>
+          <a:noFill/>
+        </p:spPr>
+        <p:txBody>
+          <a:bodyPr wrap="none" lIns="0" tIns="0" rIns="0" bIns="0">
+            <a:spAutoFit/>
+          </a:bodyPr>
+          <a:lstStyle/>
+          <a:p>
+            <a:pPr algn="l"/>
+            <a:r>
+              <a:rPr sz="800" b="1">
+                <a:solidFill>
+                  <a:srgbClr val="26CB7C"/>
+                </a:solidFill>
+                <a:latin typeface="Aptos"/>
+              </a:rPr>
+              <a:t>Takeaway</a:t>
+            </a:r>
+          </a:p>
+        </p:txBody>
+      </p:sp>
+      <p:sp>
+        <p:nvSpPr>
+          <p:cNvPr id="55" name="TextBox 54"/>
+          <p:cNvSpPr txBox="1"/>
+          <p:nvPr/>
+        </p:nvSpPr>
+        <p:spPr>
+          <a:xfrm>
+            <a:off x="8339327" y="4754880"/>
+            <a:ext cx="1993392" cy="237744"/>
+          </a:xfrm>
+          <a:prstGeom prst="rect">
+            <a:avLst/>
+          </a:prstGeom>
+          <a:noFill/>
+        </p:spPr>
+        <p:txBody>
+          <a:bodyPr wrap="none" lIns="0" tIns="0" rIns="0" bIns="0">
+            <a:spAutoFit/>
+          </a:bodyPr>
+          <a:lstStyle/>
+          <a:p>
+            <a:pPr algn="l"/>
+            <a:r>
+              <a:rPr sz="800" b="0">
+                <a:solidFill>
+                  <a:srgbClr val="F1F7FF"/>
+                </a:solidFill>
+                <a:latin typeface="Aptos"/>
+              </a:rPr>
+              <a:t>Frontend is the demo layer;
+the graded core is backend rPPG.</a:t>
+            </a:r>
+          </a:p>
+        </p:txBody>
+      </p:sp>
+      <p:sp>
+        <p:nvSpPr>
+          <p:cNvPr id="56" name="Rounded Rectangle 55"/>
+          <p:cNvSpPr/>
+          <p:nvPr/>
+        </p:nvSpPr>
+        <p:spPr>
+          <a:xfrm>
+            <a:off x="502920" y="5870448"/>
+            <a:ext cx="10744200" cy="301752"/>
+          </a:xfrm>
+          <a:prstGeom prst="roundRect">
+            <a:avLst/>
+          </a:prstGeom>
+          <a:solidFill>
+            <a:srgbClr val="0A1927"/>
+          </a:solidFill>
+          <a:ln w="9525">
+            <a:solidFill>
+              <a:srgbClr val="172F45"/>
+            </a:solidFill>
+          </a:ln>
+        </p:spPr>
+        <p:style>
+          <a:lnRef idx="1">
+            <a:schemeClr val="accent1"/>
+          </a:lnRef>
+          <a:fillRef idx="3">
+            <a:schemeClr val="accent1"/>
+          </a:fillRef>
+          <a:effectRef idx="2">
+            <a:schemeClr val="accent1"/>
+          </a:effectRef>
+          <a:fontRef idx="minor">
+            <a:schemeClr val="lt1"/>
+          </a:fontRef>
+        </p:style>
+        <p:txBody>
+          <a:bodyPr rtlCol="0" anchor="ctr"/>
+          <a:lstStyle/>
+          <a:p>
+            <a:pPr algn="ctr"/>
+            <a:endParaRPr/>
+          </a:p>
+        </p:txBody>
+      </p:sp>
+      <p:sp>
+        <p:nvSpPr>
+          <p:cNvPr id="57" name="TextBox 56"/>
+          <p:cNvSpPr txBox="1"/>
+          <p:nvPr/>
+        </p:nvSpPr>
+        <p:spPr>
+          <a:xfrm>
+            <a:off x="658368" y="5961888"/>
+            <a:ext cx="4663440" cy="118872"/>
+          </a:xfrm>
+          <a:prstGeom prst="rect">
+            <a:avLst/>
+          </a:prstGeom>
+          <a:noFill/>
+        </p:spPr>
+        <p:txBody>
+          <a:bodyPr wrap="none" lIns="0" tIns="0" rIns="0" bIns="0">
+            <a:spAutoFit/>
+          </a:bodyPr>
+          <a:lstStyle/>
+          <a:p>
+            <a:pPr algn="l"/>
+            <a:r>
+              <a:rPr sz="680" b="0">
+                <a:solidFill>
+                  <a:srgbClr val="97A8BE"/>
+                </a:solidFill>
+                <a:latin typeface="Aptos"/>
+              </a:rPr>
+              <a:t>vitalscan.bkre8tive.com  ·  github.com/gbiz21/vitalscan</a:t>
+            </a:r>
+          </a:p>
+        </p:txBody>
+      </p:sp>
+      <p:sp>
+        <p:nvSpPr>
+          <p:cNvPr id="58" name="TextBox 57"/>
+          <p:cNvSpPr txBox="1"/>
+          <p:nvPr/>
+        </p:nvSpPr>
+        <p:spPr>
+          <a:xfrm>
+            <a:off x="5138928" y="5943600"/>
+            <a:ext cx="5815584" cy="118872"/>
+          </a:xfrm>
+          <a:prstGeom prst="rect">
+            <a:avLst/>
+          </a:prstGeom>
+          <a:noFill/>
+        </p:spPr>
+        <p:txBody>
+          <a:bodyPr wrap="none" lIns="0" tIns="0" rIns="0" bIns="0">
+            <a:spAutoFit/>
+          </a:bodyPr>
+          <a:lstStyle/>
+          <a:p>
+            <a:pPr algn="r"/>
+            <a:r>
+              <a:rPr sz="680" b="0">
+                <a:solidFill>
+                  <a:srgbClr val="97A8BE"/>
+                </a:solidFill>
+                <a:latin typeface="Aptos"/>
+              </a:rPr>
+              <a:t>Build progression shows controlled system engineering — mock first, backend next, then real signal processing and evaluation.</a:t>
             </a:r>
           </a:p>
         </p:txBody>

</xml_diff>